<commit_message>
feat: Add CardStack performance case study slides and sync presentation deck
- Add 4 new slides (27-30) demonstrating O(N^2) vs O(N) list filtering in Kotlin
- Detail real-world CardStack state sync problem in Jetpack Compose
- Analyze List.contains() linear scan bottleneck and UI frame drop risk
- Showcase optimal O(N) solution using HashSet with toSet() lookup
- Update speaker notes in speaker-notes-data.js for all new slides
- Update generate_pptx.py and regenerate LeetCode_Starter_Guide.pptx
- Add .venv/ to .gitignore
</commit_message>
<xml_diff>
--- a/LeetCode_Starter_Guide.pptx
+++ b/LeetCode_Starter_Guide.pptx
@@ -34,6 +34,10 @@
     <p:sldId id="282" r:id="rId34"/>
     <p:sldId id="283" r:id="rId35"/>
     <p:sldId id="284" r:id="rId36"/>
+    <p:sldId id="285" r:id="rId37"/>
+    <p:sldId id="286" r:id="rId38"/>
+    <p:sldId id="287" r:id="rId39"/>
+    <p:sldId id="288" r:id="rId40"/>
   </p:sldIdLst>
   <p:sldSz cx="12191695" cy="6858000" type="screen4x3"/>
   <p:notesSz cx="6858000" cy="9144000"/>
@@ -1930,7 +1934,7 @@
           <a:lstStyle/>
           <a:p>
             <a:r>
-              <a:t>ارائه را با انرژی مثبت تمام کنید و حضار را تشویق کنید که همین امروز اولین مسئله را حل کنند.</a:t>
+              <a:t>بیان مسئله همگام‌سازی State در CardStack از پروژه سپینو با Jetpack Compose.</a:t>
             </a:r>
           </a:p>
         </p:txBody>
@@ -2000,7 +2004,7 @@
           <a:lstStyle/>
           <a:p>
             <a:r>
-              <a:t>پاسخ به سوالات متداول: بهترین زبان (کاتلین / پایتون)، تعداد مسئله کافی (۷۵ تا ۱۰۰ مسئله عمیق).</a:t>
+              <a:t>کد غیربهینه اولیه که در نگاه اول شیک است اما در پس‌زمینه جستجوی خطی تودرتو انجام می‌دهد.</a:t>
             </a:r>
           </a:p>
         </p:txBody>
@@ -2071,6 +2075,286 @@
           <a:p>
             <a:r>
               <a:t>استرس حضار را از بین ببرید. تشبیه به ورزش و موسیقی بزنید: هیچ‌کس در روز اول ماراتن ندویده و پیانو ننواخته است.</a:t>
+            </a:r>
+          </a:p>
+        </p:txBody>
+      </p:sp>
+      <p:sp>
+        <p:nvSpPr>
+          <p:cNvPr id="4" name="Slide Number Placeholder 3"/>
+          <p:cNvSpPr>
+            <a:spLocks noGrp="1"/>
+          </p:cNvSpPr>
+          <p:nvPr>
+            <p:ph type="sldNum" idx="5" sz="quarter"/>
+          </p:nvPr>
+        </p:nvSpPr>
+        <p:spPr/>
+      </p:sp>
+    </p:spTree>
+  </p:cSld>
+  <p:clrMapOvr>
+    <a:masterClrMapping/>
+  </p:clrMapOvr>
+</p:notes>
+</file>
+
+<file path=ppt/notesSlides/notesSlide30.xml><?xml version="1.0" encoding="utf-8"?>
+<p:notes xmlns:a="http://schemas.openxmlformats.org/drawingml/2006/main" xmlns:p="http://schemas.openxmlformats.org/presentationml/2006/main" xmlns:r="http://schemas.openxmlformats.org/officeDocument/2006/relationships">
+  <p:cSld>
+    <p:spTree>
+      <p:nvGrpSpPr>
+        <p:cNvPr id="1" name=""/>
+        <p:cNvGrpSpPr/>
+        <p:nvPr/>
+      </p:nvGrpSpPr>
+      <p:grpSpPr>
+        <a:xfrm>
+          <a:off x="0" y="0"/>
+          <a:ext cx="0" cy="0"/>
+          <a:chOff x="0" y="0"/>
+          <a:chExt cx="0" cy="0"/>
+        </a:xfrm>
+      </p:grpSpPr>
+      <p:sp>
+        <p:nvSpPr>
+          <p:cNvPr id="2" name="Slide Image Placeholder 1"/>
+          <p:cNvSpPr>
+            <a:spLocks noGrp="1"/>
+          </p:cNvSpPr>
+          <p:nvPr>
+            <p:ph type="sldImg" idx="2"/>
+          </p:nvPr>
+        </p:nvSpPr>
+        <p:spPr/>
+      </p:sp>
+      <p:sp>
+        <p:nvSpPr>
+          <p:cNvPr id="3" name="Notes Placeholder 2"/>
+          <p:cNvSpPr>
+            <a:spLocks noGrp="1"/>
+          </p:cNvSpPr>
+          <p:nvPr>
+            <p:ph type="body" idx="3" sz="quarter"/>
+          </p:nvPr>
+        </p:nvSpPr>
+        <p:spPr/>
+        <p:txBody>
+          <a:bodyPr/>
+          <a:lstStyle/>
+          <a:p>
+            <a:r>
+              <a:t>بررسی فنی علت افت فریم و نقض بودجه ۱۶ میلی‌ثانیه‌ای در اثر اجرای الگوریتم O(N²).</a:t>
+            </a:r>
+          </a:p>
+        </p:txBody>
+      </p:sp>
+      <p:sp>
+        <p:nvSpPr>
+          <p:cNvPr id="4" name="Slide Number Placeholder 3"/>
+          <p:cNvSpPr>
+            <a:spLocks noGrp="1"/>
+          </p:cNvSpPr>
+          <p:nvPr>
+            <p:ph type="sldNum" idx="5" sz="quarter"/>
+          </p:nvPr>
+        </p:nvSpPr>
+        <p:spPr/>
+      </p:sp>
+    </p:spTree>
+  </p:cSld>
+  <p:clrMapOvr>
+    <a:masterClrMapping/>
+  </p:clrMapOvr>
+</p:notes>
+</file>
+
+<file path=ppt/notesSlides/notesSlide31.xml><?xml version="1.0" encoding="utf-8"?>
+<p:notes xmlns:a="http://schemas.openxmlformats.org/drawingml/2006/main" xmlns:p="http://schemas.openxmlformats.org/presentationml/2006/main" xmlns:r="http://schemas.openxmlformats.org/officeDocument/2006/relationships">
+  <p:cSld>
+    <p:spTree>
+      <p:nvGrpSpPr>
+        <p:cNvPr id="1" name=""/>
+        <p:cNvGrpSpPr/>
+        <p:nvPr/>
+      </p:nvGrpSpPr>
+      <p:grpSpPr>
+        <a:xfrm>
+          <a:off x="0" y="0"/>
+          <a:ext cx="0" cy="0"/>
+          <a:chOff x="0" y="0"/>
+          <a:chExt cx="0" cy="0"/>
+        </a:xfrm>
+      </p:grpSpPr>
+      <p:sp>
+        <p:nvSpPr>
+          <p:cNvPr id="2" name="Slide Image Placeholder 1"/>
+          <p:cNvSpPr>
+            <a:spLocks noGrp="1"/>
+          </p:cNvSpPr>
+          <p:nvPr>
+            <p:ph type="sldImg" idx="2"/>
+          </p:nvPr>
+        </p:nvSpPr>
+        <p:spPr/>
+      </p:sp>
+      <p:sp>
+        <p:nvSpPr>
+          <p:cNvPr id="3" name="Notes Placeholder 2"/>
+          <p:cNvSpPr>
+            <a:spLocks noGrp="1"/>
+          </p:cNvSpPr>
+          <p:nvPr>
+            <p:ph type="body" idx="3" sz="quarter"/>
+          </p:nvPr>
+        </p:nvSpPr>
+        <p:spPr/>
+        <p:txBody>
+          <a:bodyPr/>
+          <a:lstStyle/>
+          <a:p>
+            <a:r>
+              <a:t>پیاده‌سازی بهینه با toSet() و توضیح تفاوت جستجوی O(1) در جدول هش با جستجوی خطی در لیست.</a:t>
+            </a:r>
+          </a:p>
+        </p:txBody>
+      </p:sp>
+      <p:sp>
+        <p:nvSpPr>
+          <p:cNvPr id="4" name="Slide Number Placeholder 3"/>
+          <p:cNvSpPr>
+            <a:spLocks noGrp="1"/>
+          </p:cNvSpPr>
+          <p:nvPr>
+            <p:ph type="sldNum" idx="5" sz="quarter"/>
+          </p:nvPr>
+        </p:nvSpPr>
+        <p:spPr/>
+      </p:sp>
+    </p:spTree>
+  </p:cSld>
+  <p:clrMapOvr>
+    <a:masterClrMapping/>
+  </p:clrMapOvr>
+</p:notes>
+</file>
+
+<file path=ppt/notesSlides/notesSlide32.xml><?xml version="1.0" encoding="utf-8"?>
+<p:notes xmlns:a="http://schemas.openxmlformats.org/drawingml/2006/main" xmlns:p="http://schemas.openxmlformats.org/presentationml/2006/main" xmlns:r="http://schemas.openxmlformats.org/officeDocument/2006/relationships">
+  <p:cSld>
+    <p:spTree>
+      <p:nvGrpSpPr>
+        <p:cNvPr id="1" name=""/>
+        <p:cNvGrpSpPr/>
+        <p:nvPr/>
+      </p:nvGrpSpPr>
+      <p:grpSpPr>
+        <a:xfrm>
+          <a:off x="0" y="0"/>
+          <a:ext cx="0" cy="0"/>
+          <a:chOff x="0" y="0"/>
+          <a:chExt cx="0" cy="0"/>
+        </a:xfrm>
+      </p:grpSpPr>
+      <p:sp>
+        <p:nvSpPr>
+          <p:cNvPr id="2" name="Slide Image Placeholder 1"/>
+          <p:cNvSpPr>
+            <a:spLocks noGrp="1"/>
+          </p:cNvSpPr>
+          <p:nvPr>
+            <p:ph type="sldImg" idx="2"/>
+          </p:nvPr>
+        </p:nvSpPr>
+        <p:spPr/>
+      </p:sp>
+      <p:sp>
+        <p:nvSpPr>
+          <p:cNvPr id="3" name="Notes Placeholder 2"/>
+          <p:cNvSpPr>
+            <a:spLocks noGrp="1"/>
+          </p:cNvSpPr>
+          <p:nvPr>
+            <p:ph type="body" idx="3" sz="quarter"/>
+          </p:nvPr>
+        </p:nvSpPr>
+        <p:spPr/>
+        <p:txBody>
+          <a:bodyPr/>
+          <a:lstStyle/>
+          <a:p>
+            <a:r>
+              <a:t>ارائه را با انرژی مثبت تمام کنید و حضار را تشویق کنید که همین امروز اولین مسئله را حل کنند.</a:t>
+            </a:r>
+          </a:p>
+        </p:txBody>
+      </p:sp>
+      <p:sp>
+        <p:nvSpPr>
+          <p:cNvPr id="4" name="Slide Number Placeholder 3"/>
+          <p:cNvSpPr>
+            <a:spLocks noGrp="1"/>
+          </p:cNvSpPr>
+          <p:nvPr>
+            <p:ph type="sldNum" idx="5" sz="quarter"/>
+          </p:nvPr>
+        </p:nvSpPr>
+        <p:spPr/>
+      </p:sp>
+    </p:spTree>
+  </p:cSld>
+  <p:clrMapOvr>
+    <a:masterClrMapping/>
+  </p:clrMapOvr>
+</p:notes>
+</file>
+
+<file path=ppt/notesSlides/notesSlide33.xml><?xml version="1.0" encoding="utf-8"?>
+<p:notes xmlns:a="http://schemas.openxmlformats.org/drawingml/2006/main" xmlns:p="http://schemas.openxmlformats.org/presentationml/2006/main" xmlns:r="http://schemas.openxmlformats.org/officeDocument/2006/relationships">
+  <p:cSld>
+    <p:spTree>
+      <p:nvGrpSpPr>
+        <p:cNvPr id="1" name=""/>
+        <p:cNvGrpSpPr/>
+        <p:nvPr/>
+      </p:nvGrpSpPr>
+      <p:grpSpPr>
+        <a:xfrm>
+          <a:off x="0" y="0"/>
+          <a:ext cx="0" cy="0"/>
+          <a:chOff x="0" y="0"/>
+          <a:chExt cx="0" cy="0"/>
+        </a:xfrm>
+      </p:grpSpPr>
+      <p:sp>
+        <p:nvSpPr>
+          <p:cNvPr id="2" name="Slide Image Placeholder 1"/>
+          <p:cNvSpPr>
+            <a:spLocks noGrp="1"/>
+          </p:cNvSpPr>
+          <p:nvPr>
+            <p:ph type="sldImg" idx="2"/>
+          </p:nvPr>
+        </p:nvSpPr>
+        <p:spPr/>
+      </p:sp>
+      <p:sp>
+        <p:nvSpPr>
+          <p:cNvPr id="3" name="Notes Placeholder 2"/>
+          <p:cNvSpPr>
+            <a:spLocks noGrp="1"/>
+          </p:cNvSpPr>
+          <p:nvPr>
+            <p:ph type="body" idx="3" sz="quarter"/>
+          </p:nvPr>
+        </p:nvSpPr>
+        <p:spPr/>
+        <p:txBody>
+          <a:bodyPr/>
+          <a:lstStyle/>
+          <a:p>
+            <a:r>
+              <a:t>پاسخ به سوالات متداول: بهترین زبان (کاتلین / پایتون)، تعداد مسئله کافی (۷۵ تا ۱۰۰ مسئله عمیق).</a:t>
             </a:r>
           </a:p>
         </p:txBody>
@@ -14388,7 +14672,7 @@
               </a:defRPr>
             </a:pPr>
             <a:r>
-              <a:t>برنامه اقدام · ACTION PLAN  |  جمع‌بندی و برنامه ۳۰ روزه آینده</a:t>
+              <a:t>تجربه عملی مهندسی · REAL-WORLD CASE STUDY  |  مطالعه موردی در پروداکشن: چالش CardStack در سپینو</a:t>
             </a:r>
           </a:p>
           <a:p>
@@ -14400,7 +14684,7 @@
               </a:defRPr>
             </a:pPr>
             <a:r>
-              <a:t>نقشه راه ۴ هفته‌ای برای رسیدن به آمادگی در جلسات ارزیابی:</a:t>
+              <a:t>الگوریتم‌ها فقط برای مصاحبه نیستند؛ انتخاب درست داده ضامن روانی رابط کاربری است:</a:t>
             </a:r>
           </a:p>
         </p:txBody>
@@ -14414,7 +14698,73 @@
         <p:spPr>
           <a:xfrm>
             <a:off x="731520" y="1463040"/>
-            <a:ext cx="2503170" cy="2011680"/>
+            <a:ext cx="5234940" cy="2011680"/>
+          </a:xfrm>
+          <a:prstGeom prst="roundRect">
+            <a:avLst/>
+          </a:prstGeom>
+          <a:solidFill>
+            <a:srgbClr val="141428"/>
+          </a:solidFill>
+          <a:ln w="19050">
+            <a:solidFill>
+              <a:srgbClr val="7C8FF5"/>
+            </a:solidFill>
+          </a:ln>
+        </p:spPr>
+        <p:style>
+          <a:lnRef idx="1">
+            <a:schemeClr val="accent1"/>
+          </a:lnRef>
+          <a:fillRef idx="3">
+            <a:schemeClr val="accent1"/>
+          </a:fillRef>
+          <a:effectRef idx="2">
+            <a:schemeClr val="accent1"/>
+          </a:effectRef>
+          <a:fontRef idx="minor">
+            <a:schemeClr val="lt1"/>
+          </a:fontRef>
+        </p:style>
+        <p:txBody>
+          <a:bodyPr rtlCol="0" anchor="ctr" wrap="square"/>
+          <a:lstStyle/>
+          <a:p>
+            <a:pPr algn="ctr">
+              <a:defRPr sz="1400" b="1">
+                <a:solidFill>
+                  <a:srgbClr val="7C8FF5"/>
+                </a:solidFill>
+              </a:defRPr>
+            </a:pPr>
+            <a:r>
+              <a:t>۱. داده‌های ورودی</a:t>
+            </a:r>
+          </a:p>
+          <a:p>
+            <a:pPr>
+              <a:defRPr sz="1100">
+                <a:solidFill>
+                  <a:srgbClr val="DDE1F5"/>
+                </a:solidFill>
+              </a:defRPr>
+            </a:pPr>
+            <a:r>
+              <a:t>دو لیست currentItems (در حال نمایش) و newCardsList (تازه از سرور).</a:t>
+            </a:r>
+          </a:p>
+        </p:txBody>
+      </p:sp>
+      <p:sp>
+        <p:nvSpPr>
+          <p:cNvPr id="5" name="Rounded Rectangle 4"/>
+          <p:cNvSpPr/>
+          <p:nvPr/>
+        </p:nvSpPr>
+        <p:spPr>
+          <a:xfrm>
+            <a:off x="6195059" y="1463040"/>
+            <a:ext cx="5234940" cy="2011680"/>
           </a:xfrm>
           <a:prstGeom prst="roundRect">
             <a:avLst/>
@@ -14454,7 +14804,7 @@
               </a:defRPr>
             </a:pPr>
             <a:r>
-              <a:t>هفته اول: مبانی آرایه و هش</a:t>
+              <a:t>۲. رفتار مورد انتظار</a:t>
             </a:r>
           </a:p>
           <a:p>
@@ -14466,139 +14816,54 @@
               </a:defRPr>
             </a:pPr>
             <a:r>
-              <a:t>حل ۵ مسئله Easy اول Blind 75 مانند Two Sum و Contains Duplicate.</a:t>
-            </a:r>
-          </a:p>
-        </p:txBody>
-      </p:sp>
-      <p:sp>
-        <p:nvSpPr>
-          <p:cNvPr id="5" name="Rounded Rectangle 4"/>
-          <p:cNvSpPr/>
-          <p:nvPr/>
-        </p:nvSpPr>
-        <p:spPr>
-          <a:xfrm>
-            <a:off x="3463289" y="1463040"/>
-            <a:ext cx="2503170" cy="2011680"/>
-          </a:xfrm>
-          <a:prstGeom prst="roundRect">
-            <a:avLst/>
-          </a:prstGeom>
-          <a:solidFill>
-            <a:srgbClr val="141428"/>
-          </a:solidFill>
-          <a:ln w="19050">
-            <a:solidFill>
-              <a:srgbClr val="7C8FF5"/>
-            </a:solidFill>
-          </a:ln>
-        </p:spPr>
-        <p:style>
-          <a:lnRef idx="1">
-            <a:schemeClr val="accent1"/>
-          </a:lnRef>
-          <a:fillRef idx="3">
-            <a:schemeClr val="accent1"/>
-          </a:fillRef>
-          <a:effectRef idx="2">
-            <a:schemeClr val="accent1"/>
-          </a:effectRef>
-          <a:fontRef idx="minor">
-            <a:schemeClr val="lt1"/>
-          </a:fontRef>
-        </p:style>
-        <p:txBody>
-          <a:bodyPr rtlCol="0" anchor="ctr" wrap="square"/>
-          <a:lstStyle/>
-          <a:p>
-            <a:pPr algn="ctr">
-              <a:defRPr sz="1400" b="1">
-                <a:solidFill>
-                  <a:srgbClr val="7C8FF5"/>
-                </a:solidFill>
-              </a:defRPr>
-            </a:pPr>
-            <a:r>
-              <a:t>هفته دوم: نشانگرها و پنجره</a:t>
-            </a:r>
-          </a:p>
-          <a:p>
-            <a:pPr>
-              <a:defRPr sz="1100">
+              <a:t>حفظ کارت‌های مشترک بدون فلیکر، حذف قدیمی‌ها، و اضافه کردن جدیدها به انتها.</a:t>
+            </a:r>
+          </a:p>
+        </p:txBody>
+      </p:sp>
+      <p:sp>
+        <p:nvSpPr>
+          <p:cNvPr id="6" name="TextBox 5"/>
+          <p:cNvSpPr txBox="1"/>
+          <p:nvPr/>
+        </p:nvSpPr>
+        <p:spPr>
+          <a:xfrm>
+            <a:off x="731520" y="3703320"/>
+            <a:ext cx="10698480" cy="1463040"/>
+          </a:xfrm>
+          <a:prstGeom prst="rect">
+            <a:avLst/>
+          </a:prstGeom>
+          <a:noFill/>
+        </p:spPr>
+        <p:txBody>
+          <a:bodyPr wrap="square">
+            <a:spAutoFit/>
+          </a:bodyPr>
+          <a:lstStyle/>
+          <a:p>
+            <a:pPr>
+              <a:defRPr sz="1300">
                 <a:solidFill>
                   <a:srgbClr val="DDE1F5"/>
                 </a:solidFill>
               </a:defRPr>
             </a:pPr>
             <a:r>
-              <a:t>الگوهای Two Pointers و Sliding Window با مرور منظم مسائل هفته اول.</a:t>
-            </a:r>
-          </a:p>
-        </p:txBody>
-      </p:sp>
-      <p:sp>
-        <p:nvSpPr>
-          <p:cNvPr id="6" name="Rounded Rectangle 5"/>
-          <p:cNvSpPr/>
-          <p:nvPr/>
-        </p:nvSpPr>
-        <p:spPr>
-          <a:xfrm>
-            <a:off x="6195059" y="1463040"/>
-            <a:ext cx="2503170" cy="2011680"/>
-          </a:xfrm>
-          <a:prstGeom prst="roundRect">
-            <a:avLst/>
-          </a:prstGeom>
-          <a:solidFill>
-            <a:srgbClr val="141428"/>
-          </a:solidFill>
-          <a:ln w="19050">
-            <a:solidFill>
-              <a:srgbClr val="E9A84C"/>
-            </a:solidFill>
-          </a:ln>
-        </p:spPr>
-        <p:style>
-          <a:lnRef idx="1">
-            <a:schemeClr val="accent1"/>
-          </a:lnRef>
-          <a:fillRef idx="3">
-            <a:schemeClr val="accent1"/>
-          </a:fillRef>
-          <a:effectRef idx="2">
-            <a:schemeClr val="accent1"/>
-          </a:effectRef>
-          <a:fontRef idx="minor">
-            <a:schemeClr val="lt1"/>
-          </a:fontRef>
-        </p:style>
-        <p:txBody>
-          <a:bodyPr rtlCol="0" anchor="ctr" wrap="square"/>
-          <a:lstStyle/>
-          <a:p>
-            <a:pPr algn="ctr">
-              <a:defRPr sz="1400" b="1">
-                <a:solidFill>
-                  <a:srgbClr val="E9A84C"/>
-                </a:solidFill>
-              </a:defRPr>
-            </a:pPr>
-            <a:r>
-              <a:t>هفته سوم: ساختارها و پشته</a:t>
-            </a:r>
-          </a:p>
-          <a:p>
-            <a:pPr>
-              <a:defRPr sz="1100">
+              <a:t>• چالش در کامپوز: پاک‌کردن و ساخت مجدد لیست باعث Recomposition سنگین و نابودی انیمیشن کارت‌ها (Jank) می‌شود.</a:t>
+            </a:r>
+          </a:p>
+          <a:p>
+            <a:pPr>
+              <a:defRPr sz="1300">
                 <a:solidFill>
                   <a:srgbClr val="DDE1F5"/>
                 </a:solidFill>
               </a:defRPr>
             </a:pPr>
             <a:r>
-              <a:t>درخت‌ها، پشته (Stack) و پیمایش‌های DFS و BFS پایه با رسم روی کاغذ.</a:t>
+              <a:t>• نیاز به تابع خالص: پیاده‌سازی syncCardStackState برای هماهنگ‌سازی بهینه پشته کارت‌ها.</a:t>
             </a:r>
           </a:p>
         </p:txBody>
@@ -14606,72 +14871,6 @@
       <p:sp>
         <p:nvSpPr>
           <p:cNvPr id="7" name="Rounded Rectangle 6"/>
-          <p:cNvSpPr/>
-          <p:nvPr/>
-        </p:nvSpPr>
-        <p:spPr>
-          <a:xfrm>
-            <a:off x="8926830" y="1463040"/>
-            <a:ext cx="2503170" cy="2011680"/>
-          </a:xfrm>
-          <a:prstGeom prst="roundRect">
-            <a:avLst/>
-          </a:prstGeom>
-          <a:solidFill>
-            <a:srgbClr val="141428"/>
-          </a:solidFill>
-          <a:ln w="19050">
-            <a:solidFill>
-              <a:srgbClr val="4ECCA3"/>
-            </a:solidFill>
-          </a:ln>
-        </p:spPr>
-        <p:style>
-          <a:lnRef idx="1">
-            <a:schemeClr val="accent1"/>
-          </a:lnRef>
-          <a:fillRef idx="3">
-            <a:schemeClr val="accent1"/>
-          </a:fillRef>
-          <a:effectRef idx="2">
-            <a:schemeClr val="accent1"/>
-          </a:effectRef>
-          <a:fontRef idx="minor">
-            <a:schemeClr val="lt1"/>
-          </a:fontRef>
-        </p:style>
-        <p:txBody>
-          <a:bodyPr rtlCol="0" anchor="ctr" wrap="square"/>
-          <a:lstStyle/>
-          <a:p>
-            <a:pPr algn="ctr">
-              <a:defRPr sz="1400" b="1">
-                <a:solidFill>
-                  <a:srgbClr val="4ECCA3"/>
-                </a:solidFill>
-              </a:defRPr>
-            </a:pPr>
-            <a:r>
-              <a:t>هفته چهارم: تست‌های Medium</a:t>
-            </a:r>
-          </a:p>
-          <a:p>
-            <a:pPr>
-              <a:defRPr sz="1100">
-                <a:solidFill>
-                  <a:srgbClr val="DDE1F5"/>
-                </a:solidFill>
-              </a:defRPr>
-            </a:pPr>
-            <a:r>
-              <a:t>ورود به مسائل سطح Medium و تمرین با تایمر ۳۰ دقیقه‌ای ارزیابی.</a:t>
-            </a:r>
-          </a:p>
-        </p:txBody>
-      </p:sp>
-      <p:sp>
-        <p:nvSpPr>
-          <p:cNvPr id="8" name="Rounded Rectangle 7"/>
           <p:cNvSpPr/>
           <p:nvPr/>
         </p:nvSpPr>
@@ -14718,7 +14917,7 @@
               </a:defRPr>
             </a:pPr>
             <a:r>
-              <a:t>«پیوستگی روزانه ۴۵ دقیقه تمرین عمیق، معجزه‌ای خلق می‌کند که تمرین‌های ۱۰ ساعته‌ی بی‌هدف هرگز نخواهد کرد.»</a:t>
+              <a:t>«تفاوت مهندس ارشد با کدنویس معمولی در توانایی شناسایی پیچیدگی الگوریتمی کدهای به ظاهر ساده کاتلین است.»</a:t>
             </a:r>
           </a:p>
         </p:txBody>
@@ -14792,8 +14991,8 @@
         </p:nvSpPr>
         <p:spPr>
           <a:xfrm>
-            <a:off x="1371600" y="1645920"/>
-            <a:ext cx="9418320" cy="3657600"/>
+            <a:off x="731520" y="365760"/>
+            <a:ext cx="10698480" cy="914400"/>
           </a:xfrm>
           <a:prstGeom prst="rect">
             <a:avLst/>
@@ -14806,52 +15005,384 @@
           </a:bodyPr>
           <a:lstStyle/>
           <a:p>
+            <a:pPr>
+              <a:defRPr sz="2400" b="1">
+                <a:solidFill>
+                  <a:srgbClr val="4ECCA3"/>
+                </a:solidFill>
+              </a:defRPr>
+            </a:pPr>
+            <a:r>
+              <a:t>کد غیربهینه · BRUTE FORCE O(N²)  |  راه‌حل اول (غیربهینه): فیلتر مستقیم روی List</a:t>
+            </a:r>
+          </a:p>
+          <a:p>
+            <a:pPr>
+              <a:defRPr sz="1400">
+                <a:solidFill>
+                  <a:srgbClr val="969EB4"/>
+                </a:solidFill>
+              </a:defRPr>
+            </a:pPr>
+            <a:r>
+              <a:t>استفاده فریبنده از ابزارهای اعلانی کاتلین بدون توجه به پیچیدگی زیر کاپوت:</a:t>
+            </a:r>
+          </a:p>
+        </p:txBody>
+      </p:sp>
+      <p:sp>
+        <p:nvSpPr>
+          <p:cNvPr id="4" name="Rounded Rectangle 3"/>
+          <p:cNvSpPr/>
+          <p:nvPr/>
+        </p:nvSpPr>
+        <p:spPr>
+          <a:xfrm>
+            <a:off x="731520" y="1463040"/>
+            <a:ext cx="3413759" cy="2011680"/>
+          </a:xfrm>
+          <a:prstGeom prst="roundRect">
+            <a:avLst/>
+          </a:prstGeom>
+          <a:solidFill>
+            <a:srgbClr val="141428"/>
+          </a:solidFill>
+          <a:ln w="19050">
+            <a:solidFill>
+              <a:srgbClr val="E9A84C"/>
+            </a:solidFill>
+          </a:ln>
+        </p:spPr>
+        <p:style>
+          <a:lnRef idx="1">
+            <a:schemeClr val="accent1"/>
+          </a:lnRef>
+          <a:fillRef idx="3">
+            <a:schemeClr val="accent1"/>
+          </a:fillRef>
+          <a:effectRef idx="2">
+            <a:schemeClr val="accent1"/>
+          </a:effectRef>
+          <a:fontRef idx="minor">
+            <a:schemeClr val="lt1"/>
+          </a:fontRef>
+        </p:style>
+        <p:txBody>
+          <a:bodyPr rtlCol="0" anchor="ctr" wrap="square"/>
+          <a:lstStyle/>
+          <a:p>
             <a:pPr algn="ctr">
-              <a:defRPr sz="4600" b="1">
+              <a:defRPr sz="1400" b="1">
+                <a:solidFill>
+                  <a:srgbClr val="E9A84C"/>
+                </a:solidFill>
+              </a:defRPr>
+            </a:pPr>
+            <a:r>
+              <a:t>ظاهر فریبنده کاتلین</a:t>
+            </a:r>
+          </a:p>
+          <a:p>
+            <a:pPr>
+              <a:defRPr sz="1100">
+                <a:solidFill>
+                  <a:srgbClr val="DDE1F5"/>
+                </a:solidFill>
+              </a:defRPr>
+            </a:pPr>
+            <a:r>
+              <a:t>کد فقط ۲ خط و بسیار خواناست و تست‌های کوچک را به راحتی پاس می‌کند.</a:t>
+            </a:r>
+          </a:p>
+        </p:txBody>
+      </p:sp>
+      <p:sp>
+        <p:nvSpPr>
+          <p:cNvPr id="5" name="Rounded Rectangle 4"/>
+          <p:cNvSpPr/>
+          <p:nvPr/>
+        </p:nvSpPr>
+        <p:spPr>
+          <a:xfrm>
+            <a:off x="4373880" y="1463040"/>
+            <a:ext cx="3413759" cy="2011680"/>
+          </a:xfrm>
+          <a:prstGeom prst="roundRect">
+            <a:avLst/>
+          </a:prstGeom>
+          <a:solidFill>
+            <a:srgbClr val="141428"/>
+          </a:solidFill>
+          <a:ln w="19050">
+            <a:solidFill>
+              <a:srgbClr val="E96C6C"/>
+            </a:solidFill>
+          </a:ln>
+        </p:spPr>
+        <p:style>
+          <a:lnRef idx="1">
+            <a:schemeClr val="accent1"/>
+          </a:lnRef>
+          <a:fillRef idx="3">
+            <a:schemeClr val="accent1"/>
+          </a:fillRef>
+          <a:effectRef idx="2">
+            <a:schemeClr val="accent1"/>
+          </a:effectRef>
+          <a:fontRef idx="minor">
+            <a:schemeClr val="lt1"/>
+          </a:fontRef>
+        </p:style>
+        <p:txBody>
+          <a:bodyPr rtlCol="0" anchor="ctr" wrap="square"/>
+          <a:lstStyle/>
+          <a:p>
+            <a:pPr algn="ctr">
+              <a:defRPr sz="1400" b="1">
+                <a:solidFill>
+                  <a:srgbClr val="E96C6C"/>
+                </a:solidFill>
+              </a:defRPr>
+            </a:pPr>
+            <a:r>
+              <a:t>زیر کاپوت عملگر in</a:t>
+            </a:r>
+          </a:p>
+          <a:p>
+            <a:pPr>
+              <a:defRPr sz="1100">
+                <a:solidFill>
+                  <a:srgbClr val="DDE1F5"/>
+                </a:solidFill>
+              </a:defRPr>
+            </a:pPr>
+            <a:r>
+              <a:t>در List، عملگر in معادل contains() با پیمایش خطی O(M) است.</a:t>
+            </a:r>
+          </a:p>
+        </p:txBody>
+      </p:sp>
+      <p:sp>
+        <p:nvSpPr>
+          <p:cNvPr id="6" name="Rounded Rectangle 5"/>
+          <p:cNvSpPr/>
+          <p:nvPr/>
+        </p:nvSpPr>
+        <p:spPr>
+          <a:xfrm>
+            <a:off x="8016239" y="1463040"/>
+            <a:ext cx="3413759" cy="2011680"/>
+          </a:xfrm>
+          <a:prstGeom prst="roundRect">
+            <a:avLst/>
+          </a:prstGeom>
+          <a:solidFill>
+            <a:srgbClr val="141428"/>
+          </a:solidFill>
+          <a:ln w="19050">
+            <a:solidFill>
+              <a:srgbClr val="E96C6C"/>
+            </a:solidFill>
+          </a:ln>
+        </p:spPr>
+        <p:style>
+          <a:lnRef idx="1">
+            <a:schemeClr val="accent1"/>
+          </a:lnRef>
+          <a:fillRef idx="3">
+            <a:schemeClr val="accent1"/>
+          </a:fillRef>
+          <a:effectRef idx="2">
+            <a:schemeClr val="accent1"/>
+          </a:effectRef>
+          <a:fontRef idx="minor">
+            <a:schemeClr val="lt1"/>
+          </a:fontRef>
+        </p:style>
+        <p:txBody>
+          <a:bodyPr rtlCol="0" anchor="ctr" wrap="square"/>
+          <a:lstStyle/>
+          <a:p>
+            <a:pPr algn="ctr">
+              <a:defRPr sz="1400" b="1">
+                <a:solidFill>
+                  <a:srgbClr val="E96C6C"/>
+                </a:solidFill>
+              </a:defRPr>
+            </a:pPr>
+            <a:r>
+              <a:t>پیچیدگی نمایی</a:t>
+            </a:r>
+          </a:p>
+          <a:p>
+            <a:pPr>
+              <a:defRPr sz="1100">
+                <a:solidFill>
+                  <a:srgbClr val="DDE1F5"/>
+                </a:solidFill>
+              </a:defRPr>
+            </a:pPr>
+            <a:r>
+              <a:t>برای دو لیست با اندازه N و M، کل مقایسه‌ها O(N × M) یعنی O(N²) است!</a:t>
+            </a:r>
+          </a:p>
+        </p:txBody>
+      </p:sp>
+      <p:sp>
+        <p:nvSpPr>
+          <p:cNvPr id="7" name="Rounded Rectangle 6"/>
+          <p:cNvSpPr/>
+          <p:nvPr/>
+        </p:nvSpPr>
+        <p:spPr>
+          <a:xfrm>
+            <a:off x="731520" y="3703320"/>
+            <a:ext cx="10698480" cy="2212848"/>
+          </a:xfrm>
+          <a:prstGeom prst="roundRect">
+            <a:avLst/>
+          </a:prstGeom>
+          <a:solidFill>
+            <a:srgbClr val="08080F"/>
+          </a:solidFill>
+          <a:ln w="12700">
+            <a:solidFill>
+              <a:srgbClr val="7C8FF5"/>
+            </a:solidFill>
+          </a:ln>
+        </p:spPr>
+        <p:style>
+          <a:lnRef idx="1">
+            <a:schemeClr val="accent1"/>
+          </a:lnRef>
+          <a:fillRef idx="3">
+            <a:schemeClr val="accent1"/>
+          </a:fillRef>
+          <a:effectRef idx="2">
+            <a:schemeClr val="accent1"/>
+          </a:effectRef>
+          <a:fontRef idx="minor">
+            <a:schemeClr val="lt1"/>
+          </a:fontRef>
+        </p:style>
+        <p:txBody>
+          <a:bodyPr rtlCol="0" anchor="ctr" wrap="none"/>
+          <a:lstStyle/>
+          <a:p>
+            <a:pPr algn="l">
+              <a:defRPr sz="1100">
                 <a:solidFill>
                   <a:srgbClr val="4ECCA3"/>
                 </a:solidFill>
-              </a:defRPr>
-            </a:pPr>
-            <a:r>
-              <a:t>متشکرم از همراهی شما</a:t>
-            </a:r>
-          </a:p>
-          <a:p>
-            <a:pPr algn="ctr">
-              <a:defRPr sz="2800">
-                <a:solidFill>
-                  <a:srgbClr val="7C8FF5"/>
-                </a:solidFill>
-              </a:defRPr>
-            </a:pPr>
-            <a:r>
-              <a:t>پرسش و پاسخ (Q&amp;A)</a:t>
-            </a:r>
-          </a:p>
-          <a:p>
-            <a:br/>
-            <a:pPr algn="ctr">
-              <a:defRPr sz="2000">
-                <a:solidFill>
-                  <a:srgbClr val="DDE1F5"/>
-                </a:solidFill>
-              </a:defRPr>
-            </a:pPr>
-            <a:r>
-              <a:t>Milad Faridnia</a:t>
-            </a:r>
-          </a:p>
-          <a:p>
-            <a:pPr algn="ctr">
-              <a:defRPr sz="1400">
-                <a:solidFill>
-                  <a:srgbClr val="E9A84C"/>
-                </a:solidFill>
-              </a:defRPr>
-            </a:pPr>
-            <a:r>
-              <a:t>LeetCode.com · NeetCode.io · Blind 75</a:t>
+                <a:latin typeface="Consolas"/>
+              </a:defRPr>
+            </a:pPr>
+            <a:r>
+              <a:t>// ❌ رویکرد کُند: جستجوی مستقیم در List با O(N²)</a:t>
+            </a:r>
+          </a:p>
+          <a:p>
+            <a:pPr algn="l">
+              <a:defRPr sz="1100">
+                <a:solidFill>
+                  <a:srgbClr val="4ECCA3"/>
+                </a:solidFill>
+                <a:latin typeface="Consolas"/>
+              </a:defRPr>
+            </a:pPr>
+            <a:r>
+              <a:t>internal fun &lt;T&gt; syncCardStackState(</a:t>
+            </a:r>
+          </a:p>
+          <a:p>
+            <a:pPr algn="l">
+              <a:defRPr sz="1100">
+                <a:solidFill>
+                  <a:srgbClr val="4ECCA3"/>
+                </a:solidFill>
+                <a:latin typeface="Consolas"/>
+              </a:defRPr>
+            </a:pPr>
+            <a:r>
+              <a:t>    currentItems: List&lt;T&gt;,</a:t>
+            </a:r>
+          </a:p>
+          <a:p>
+            <a:pPr algn="l">
+              <a:defRPr sz="1100">
+                <a:solidFill>
+                  <a:srgbClr val="4ECCA3"/>
+                </a:solidFill>
+                <a:latin typeface="Consolas"/>
+              </a:defRPr>
+            </a:pPr>
+            <a:r>
+              <a:t>    newCardsList: List&lt;T&gt;,</a:t>
+            </a:r>
+          </a:p>
+          <a:p>
+            <a:pPr algn="l">
+              <a:defRPr sz="1100">
+                <a:solidFill>
+                  <a:srgbClr val="4ECCA3"/>
+                </a:solidFill>
+                <a:latin typeface="Consolas"/>
+              </a:defRPr>
+            </a:pPr>
+            <a:r>
+              <a:t>): List&lt;T&gt; {</a:t>
+            </a:r>
+          </a:p>
+          <a:p>
+            <a:pPr algn="l">
+              <a:defRPr sz="1100">
+                <a:solidFill>
+                  <a:srgbClr val="4ECCA3"/>
+                </a:solidFill>
+                <a:latin typeface="Consolas"/>
+              </a:defRPr>
+            </a:pPr>
+            <a:r>
+              <a:t>    val remainingOldItems = currentItems.filter { it in newCardsList }</a:t>
+            </a:r>
+          </a:p>
+          <a:p>
+            <a:pPr algn="l">
+              <a:defRPr sz="1100">
+                <a:solidFill>
+                  <a:srgbClr val="4ECCA3"/>
+                </a:solidFill>
+                <a:latin typeface="Consolas"/>
+              </a:defRPr>
+            </a:pPr>
+            <a:r>
+              <a:t>    val newItems = newCardsList.filter { it !in currentItems }</a:t>
+            </a:r>
+          </a:p>
+          <a:p>
+            <a:pPr algn="l">
+              <a:defRPr sz="1100">
+                <a:solidFill>
+                  <a:srgbClr val="4ECCA3"/>
+                </a:solidFill>
+                <a:latin typeface="Consolas"/>
+              </a:defRPr>
+            </a:pPr>
+            <a:r>
+              <a:t>    return remainingOldItems + newItems</a:t>
+            </a:r>
+          </a:p>
+          <a:p>
+            <a:pPr algn="l">
+              <a:defRPr sz="1100">
+                <a:solidFill>
+                  <a:srgbClr val="4ECCA3"/>
+                </a:solidFill>
+                <a:latin typeface="Consolas"/>
+              </a:defRPr>
+            </a:pPr>
+            <a:r>
+              <a:t>}</a:t>
             </a:r>
           </a:p>
         </p:txBody>
@@ -15151,6 +15682,1385 @@
             </a:pPr>
             <a:r>
               <a:t>• فاز ۳ (شهود و تسلط): نگاه به صورت مسئله بلافاصله ساختار داده مناسب را در ذهن ترسیم می‌کند.</a:t>
+            </a:r>
+          </a:p>
+        </p:txBody>
+      </p:sp>
+    </p:spTree>
+  </p:cSld>
+  <p:clrMapOvr>
+    <a:masterClrMapping/>
+  </p:clrMapOvr>
+</p:sld>
+</file>
+
+<file path=ppt/slides/slide30.xml><?xml version="1.0" encoding="utf-8"?>
+<p:sld xmlns:a="http://schemas.openxmlformats.org/drawingml/2006/main" xmlns:p="http://schemas.openxmlformats.org/presentationml/2006/main" xmlns:r="http://schemas.openxmlformats.org/officeDocument/2006/relationships">
+  <p:cSld>
+    <p:spTree>
+      <p:nvGrpSpPr>
+        <p:cNvPr id="1" name=""/>
+        <p:cNvGrpSpPr/>
+        <p:nvPr/>
+      </p:nvGrpSpPr>
+      <p:grpSpPr/>
+      <p:sp>
+        <p:nvSpPr>
+          <p:cNvPr id="2" name="Rectangle 1"/>
+          <p:cNvSpPr/>
+          <p:nvPr/>
+        </p:nvSpPr>
+        <p:spPr>
+          <a:xfrm>
+            <a:off x="0" y="0"/>
+            <a:ext cx="12191695" cy="6858000"/>
+          </a:xfrm>
+          <a:prstGeom prst="rect">
+            <a:avLst/>
+          </a:prstGeom>
+          <a:solidFill>
+            <a:srgbClr val="0D0D1A"/>
+          </a:solidFill>
+          <a:ln>
+            <a:noFill/>
+          </a:ln>
+        </p:spPr>
+        <p:style>
+          <a:lnRef idx="1">
+            <a:schemeClr val="accent1"/>
+          </a:lnRef>
+          <a:fillRef idx="3">
+            <a:schemeClr val="accent1"/>
+          </a:fillRef>
+          <a:effectRef idx="2">
+            <a:schemeClr val="accent1"/>
+          </a:effectRef>
+          <a:fontRef idx="minor">
+            <a:schemeClr val="lt1"/>
+          </a:fontRef>
+        </p:style>
+        <p:txBody>
+          <a:bodyPr rtlCol="0" anchor="ctr"/>
+          <a:lstStyle/>
+          <a:p>
+            <a:pPr algn="ctr"/>
+          </a:p>
+        </p:txBody>
+      </p:sp>
+      <p:sp>
+        <p:nvSpPr>
+          <p:cNvPr id="3" name="TextBox 2"/>
+          <p:cNvSpPr txBox="1"/>
+          <p:nvPr/>
+        </p:nvSpPr>
+        <p:spPr>
+          <a:xfrm>
+            <a:off x="731520" y="365760"/>
+            <a:ext cx="10698480" cy="914400"/>
+          </a:xfrm>
+          <a:prstGeom prst="rect">
+            <a:avLst/>
+          </a:prstGeom>
+          <a:noFill/>
+        </p:spPr>
+        <p:txBody>
+          <a:bodyPr wrap="square">
+            <a:spAutoFit/>
+          </a:bodyPr>
+          <a:lstStyle/>
+          <a:p>
+            <a:pPr>
+              <a:defRPr sz="2400" b="1">
+                <a:solidFill>
+                  <a:srgbClr val="4ECCA3"/>
+                </a:solidFill>
+              </a:defRPr>
+            </a:pPr>
+            <a:r>
+              <a:t>تحلیل گلوگاه · BOTTLENECK ANALYSIS  |  کالبدشکافی ایراد: هزینه پنهان و افت فریم در UI</a:t>
+            </a:r>
+          </a:p>
+          <a:p>
+            <a:pPr>
+              <a:defRPr sz="1400">
+                <a:solidFill>
+                  <a:srgbClr val="969EB4"/>
+                </a:solidFill>
+              </a:defRPr>
+            </a:pPr>
+            <a:r>
+              <a:t>چرا این کد در محیط پروداکشن باعث لگ و مصرف غیرعادی باتری می‌شود؟</a:t>
+            </a:r>
+          </a:p>
+        </p:txBody>
+      </p:sp>
+      <p:sp>
+        <p:nvSpPr>
+          <p:cNvPr id="4" name="Rounded Rectangle 3"/>
+          <p:cNvSpPr/>
+          <p:nvPr/>
+        </p:nvSpPr>
+        <p:spPr>
+          <a:xfrm>
+            <a:off x="731520" y="1463040"/>
+            <a:ext cx="5234940" cy="2011680"/>
+          </a:xfrm>
+          <a:prstGeom prst="roundRect">
+            <a:avLst/>
+          </a:prstGeom>
+          <a:solidFill>
+            <a:srgbClr val="141428"/>
+          </a:solidFill>
+          <a:ln w="19050">
+            <a:solidFill>
+              <a:srgbClr val="E96C6C"/>
+            </a:solidFill>
+          </a:ln>
+        </p:spPr>
+        <p:style>
+          <a:lnRef idx="1">
+            <a:schemeClr val="accent1"/>
+          </a:lnRef>
+          <a:fillRef idx="3">
+            <a:schemeClr val="accent1"/>
+          </a:fillRef>
+          <a:effectRef idx="2">
+            <a:schemeClr val="accent1"/>
+          </a:effectRef>
+          <a:fontRef idx="minor">
+            <a:schemeClr val="lt1"/>
+          </a:fontRef>
+        </p:style>
+        <p:txBody>
+          <a:bodyPr rtlCol="0" anchor="ctr" wrap="square"/>
+          <a:lstStyle/>
+          <a:p>
+            <a:pPr algn="ctr">
+              <a:defRPr sz="1400" b="1">
+                <a:solidFill>
+                  <a:srgbClr val="E96C6C"/>
+                </a:solidFill>
+              </a:defRPr>
+            </a:pPr>
+            <a:r>
+              <a:t>❌ پیمایش خطی مداوم (Linear Scan)</a:t>
+            </a:r>
+          </a:p>
+          <a:p>
+            <a:pPr>
+              <a:defRPr sz="1100">
+                <a:solidFill>
+                  <a:srgbClr val="DDE1F5"/>
+                </a:solidFill>
+              </a:defRPr>
+            </a:pPr>
+            <a:r>
+              <a:t>ساختار List ترتیبی است؛ ترکیب آن با filter یک حلقه تو در تو (Nested Loop) پنهان است.</a:t>
+            </a:r>
+          </a:p>
+        </p:txBody>
+      </p:sp>
+      <p:sp>
+        <p:nvSpPr>
+          <p:cNvPr id="5" name="Rounded Rectangle 4"/>
+          <p:cNvSpPr/>
+          <p:nvPr/>
+        </p:nvSpPr>
+        <p:spPr>
+          <a:xfrm>
+            <a:off x="6195059" y="1463040"/>
+            <a:ext cx="5234940" cy="2011680"/>
+          </a:xfrm>
+          <a:prstGeom prst="roundRect">
+            <a:avLst/>
+          </a:prstGeom>
+          <a:solidFill>
+            <a:srgbClr val="141428"/>
+          </a:solidFill>
+          <a:ln w="19050">
+            <a:solidFill>
+              <a:srgbClr val="E9A84C"/>
+            </a:solidFill>
+          </a:ln>
+        </p:spPr>
+        <p:style>
+          <a:lnRef idx="1">
+            <a:schemeClr val="accent1"/>
+          </a:lnRef>
+          <a:fillRef idx="3">
+            <a:schemeClr val="accent1"/>
+          </a:fillRef>
+          <a:effectRef idx="2">
+            <a:schemeClr val="accent1"/>
+          </a:effectRef>
+          <a:fontRef idx="minor">
+            <a:schemeClr val="lt1"/>
+          </a:fontRef>
+        </p:style>
+        <p:txBody>
+          <a:bodyPr rtlCol="0" anchor="ctr" wrap="square"/>
+          <a:lstStyle/>
+          <a:p>
+            <a:pPr algn="ctr">
+              <a:defRPr sz="1400" b="1">
+                <a:solidFill>
+                  <a:srgbClr val="E9A84C"/>
+                </a:solidFill>
+              </a:defRPr>
+            </a:pPr>
+            <a:r>
+              <a:t>⚠️ افت فریم و لگ در کامپوز (Jank)</a:t>
+            </a:r>
+          </a:p>
+          <a:p>
+            <a:pPr>
+              <a:defRPr sz="1100">
+                <a:solidFill>
+                  <a:srgbClr val="DDE1F5"/>
+                </a:solidFill>
+              </a:defRPr>
+            </a:pPr>
+            <a:r>
+              <a:t>در Compose محاسبه State روی Main Thread است؛ هزاران مقایسه باعث گذر از بودجه ۱۶ میلی‌ثانیه‌ای فریم می‌شود.</a:t>
+            </a:r>
+          </a:p>
+        </p:txBody>
+      </p:sp>
+      <p:sp>
+        <p:nvSpPr>
+          <p:cNvPr id="6" name="TextBox 5"/>
+          <p:cNvSpPr txBox="1"/>
+          <p:nvPr/>
+        </p:nvSpPr>
+        <p:spPr>
+          <a:xfrm>
+            <a:off x="731520" y="3703320"/>
+            <a:ext cx="10698480" cy="1463040"/>
+          </a:xfrm>
+          <a:prstGeom prst="rect">
+            <a:avLst/>
+          </a:prstGeom>
+          <a:noFill/>
+        </p:spPr>
+        <p:txBody>
+          <a:bodyPr wrap="square">
+            <a:spAutoFit/>
+          </a:bodyPr>
+          <a:lstStyle/>
+          <a:p>
+            <a:pPr>
+              <a:defRPr sz="1300">
+                <a:solidFill>
+                  <a:srgbClr val="DDE1F5"/>
+                </a:solidFill>
+              </a:defRPr>
+            </a:pPr>
+            <a:r>
+              <a:t>• پنهان از چشم لینترها: Detekt و کامپایلر ایراد سینتکسی نمی‌گیرند؛ اما Profiler فریز فریم‌ها را ثبت می‌کند.</a:t>
+            </a:r>
+          </a:p>
+          <a:p>
+            <a:pPr>
+              <a:defRPr sz="1300">
+                <a:solidFill>
+                  <a:srgbClr val="DDE1F5"/>
+                </a:solidFill>
+              </a:defRPr>
+            </a:pPr>
+            <a:r>
+              <a:t>• در مقیاس ۵۰ تا ۱۰۰ کارت: ۲۰,۰۰۰ عملیات مقایسه سنگین شیء رخ می‌دهد.</a:t>
+            </a:r>
+          </a:p>
+        </p:txBody>
+      </p:sp>
+      <p:sp>
+        <p:nvSpPr>
+          <p:cNvPr id="7" name="Rounded Rectangle 6"/>
+          <p:cNvSpPr/>
+          <p:nvPr/>
+        </p:nvSpPr>
+        <p:spPr>
+          <a:xfrm>
+            <a:off x="731520" y="5486400"/>
+            <a:ext cx="10698480" cy="822960"/>
+          </a:xfrm>
+          <a:prstGeom prst="roundRect">
+            <a:avLst/>
+          </a:prstGeom>
+          <a:solidFill>
+            <a:srgbClr val="1C1C38"/>
+          </a:solidFill>
+          <a:ln w="12700">
+            <a:solidFill>
+              <a:srgbClr val="7C8FF5"/>
+            </a:solidFill>
+          </a:ln>
+        </p:spPr>
+        <p:style>
+          <a:lnRef idx="1">
+            <a:schemeClr val="accent1"/>
+          </a:lnRef>
+          <a:fillRef idx="3">
+            <a:schemeClr val="accent1"/>
+          </a:fillRef>
+          <a:effectRef idx="2">
+            <a:schemeClr val="accent1"/>
+          </a:effectRef>
+          <a:fontRef idx="minor">
+            <a:schemeClr val="lt1"/>
+          </a:fontRef>
+        </p:style>
+        <p:txBody>
+          <a:bodyPr rtlCol="0" anchor="ctr" wrap="square"/>
+          <a:lstStyle/>
+          <a:p>
+            <a:pPr algn="ctr">
+              <a:defRPr sz="1200" i="1">
+                <a:solidFill>
+                  <a:srgbClr val="7C8FF5"/>
+                </a:solidFill>
+              </a:defRPr>
+            </a:pPr>
+            <a:r>
+              <a:t>«در ۶۰ فریم بر ثانیه، هر فریم فقط ۱۶ میلی‌ثانیه زمان دارد؛ حلقه‌های O(N²) اولین قاتل روانی UI هستند.»</a:t>
+            </a:r>
+          </a:p>
+        </p:txBody>
+      </p:sp>
+    </p:spTree>
+  </p:cSld>
+  <p:clrMapOvr>
+    <a:masterClrMapping/>
+  </p:clrMapOvr>
+</p:sld>
+</file>
+
+<file path=ppt/slides/slide31.xml><?xml version="1.0" encoding="utf-8"?>
+<p:sld xmlns:a="http://schemas.openxmlformats.org/drawingml/2006/main" xmlns:p="http://schemas.openxmlformats.org/presentationml/2006/main" xmlns:r="http://schemas.openxmlformats.org/officeDocument/2006/relationships">
+  <p:cSld>
+    <p:spTree>
+      <p:nvGrpSpPr>
+        <p:cNvPr id="1" name=""/>
+        <p:cNvGrpSpPr/>
+        <p:nvPr/>
+      </p:nvGrpSpPr>
+      <p:grpSpPr/>
+      <p:sp>
+        <p:nvSpPr>
+          <p:cNvPr id="2" name="Rectangle 1"/>
+          <p:cNvSpPr/>
+          <p:nvPr/>
+        </p:nvSpPr>
+        <p:spPr>
+          <a:xfrm>
+            <a:off x="0" y="0"/>
+            <a:ext cx="12191695" cy="6858000"/>
+          </a:xfrm>
+          <a:prstGeom prst="rect">
+            <a:avLst/>
+          </a:prstGeom>
+          <a:solidFill>
+            <a:srgbClr val="0D0D1A"/>
+          </a:solidFill>
+          <a:ln>
+            <a:noFill/>
+          </a:ln>
+        </p:spPr>
+        <p:style>
+          <a:lnRef idx="1">
+            <a:schemeClr val="accent1"/>
+          </a:lnRef>
+          <a:fillRef idx="3">
+            <a:schemeClr val="accent1"/>
+          </a:fillRef>
+          <a:effectRef idx="2">
+            <a:schemeClr val="accent1"/>
+          </a:effectRef>
+          <a:fontRef idx="minor">
+            <a:schemeClr val="lt1"/>
+          </a:fontRef>
+        </p:style>
+        <p:txBody>
+          <a:bodyPr rtlCol="0" anchor="ctr"/>
+          <a:lstStyle/>
+          <a:p>
+            <a:pPr algn="ctr"/>
+          </a:p>
+        </p:txBody>
+      </p:sp>
+      <p:sp>
+        <p:nvSpPr>
+          <p:cNvPr id="3" name="TextBox 2"/>
+          <p:cNvSpPr txBox="1"/>
+          <p:nvPr/>
+        </p:nvSpPr>
+        <p:spPr>
+          <a:xfrm>
+            <a:off x="731520" y="365760"/>
+            <a:ext cx="10698480" cy="914400"/>
+          </a:xfrm>
+          <a:prstGeom prst="rect">
+            <a:avLst/>
+          </a:prstGeom>
+          <a:noFill/>
+        </p:spPr>
+        <p:txBody>
+          <a:bodyPr wrap="square">
+            <a:spAutoFit/>
+          </a:bodyPr>
+          <a:lstStyle/>
+          <a:p>
+            <a:pPr>
+              <a:defRPr sz="2400" b="1">
+                <a:solidFill>
+                  <a:srgbClr val="4ECCA3"/>
+                </a:solidFill>
+              </a:defRPr>
+            </a:pPr>
+            <a:r>
+              <a:t>کدنویسی تمیز · OPTIMAL O(N)  |  راه‌حل بهینه: جهش به O(N) با HashSet و تحلیل چرایی</a:t>
+            </a:r>
+          </a:p>
+          <a:p>
+            <a:pPr>
+              <a:defRPr sz="1400">
+                <a:solidFill>
+                  <a:srgbClr val="969EB4"/>
+                </a:solidFill>
+              </a:defRPr>
+            </a:pPr>
+            <a:r>
+              <a:t>به‌کارگیری جدول هش برای جستجوی آنی O(1) و کاهش زمان کل به خطی O(N + M):</a:t>
+            </a:r>
+          </a:p>
+        </p:txBody>
+      </p:sp>
+      <p:sp>
+        <p:nvSpPr>
+          <p:cNvPr id="4" name="Rounded Rectangle 3"/>
+          <p:cNvSpPr/>
+          <p:nvPr/>
+        </p:nvSpPr>
+        <p:spPr>
+          <a:xfrm>
+            <a:off x="731520" y="1463040"/>
+            <a:ext cx="5234940" cy="2011680"/>
+          </a:xfrm>
+          <a:prstGeom prst="roundRect">
+            <a:avLst/>
+          </a:prstGeom>
+          <a:solidFill>
+            <a:srgbClr val="141428"/>
+          </a:solidFill>
+          <a:ln w="19050">
+            <a:solidFill>
+              <a:srgbClr val="4ECCA3"/>
+            </a:solidFill>
+          </a:ln>
+        </p:spPr>
+        <p:style>
+          <a:lnRef idx="1">
+            <a:schemeClr val="accent1"/>
+          </a:lnRef>
+          <a:fillRef idx="3">
+            <a:schemeClr val="accent1"/>
+          </a:fillRef>
+          <a:effectRef idx="2">
+            <a:schemeClr val="accent1"/>
+          </a:effectRef>
+          <a:fontRef idx="minor">
+            <a:schemeClr val="lt1"/>
+          </a:fontRef>
+        </p:style>
+        <p:txBody>
+          <a:bodyPr rtlCol="0" anchor="ctr" wrap="square"/>
+          <a:lstStyle/>
+          <a:p>
+            <a:pPr algn="ctr">
+              <a:defRPr sz="1400" b="1">
+                <a:solidFill>
+                  <a:srgbClr val="4ECCA3"/>
+                </a:solidFill>
+              </a:defRPr>
+            </a:pPr>
+            <a:r>
+              <a:t>⚡ جستجوی آنی O(1)</a:t>
+            </a:r>
+          </a:p>
+          <a:p>
+            <a:pPr>
+              <a:defRPr sz="1100">
+                <a:solidFill>
+                  <a:srgbClr val="DDE1F5"/>
+                </a:solidFill>
+              </a:defRPr>
+            </a:pPr>
+            <a:r>
+              <a:t>با toSet() جدول هش ساخته می‌شود و جستجو با تابع هش در زمان ثابت انجام می‌گیرد.</a:t>
+            </a:r>
+          </a:p>
+        </p:txBody>
+      </p:sp>
+      <p:sp>
+        <p:nvSpPr>
+          <p:cNvPr id="5" name="Rounded Rectangle 4"/>
+          <p:cNvSpPr/>
+          <p:nvPr/>
+        </p:nvSpPr>
+        <p:spPr>
+          <a:xfrm>
+            <a:off x="6195059" y="1463040"/>
+            <a:ext cx="5234940" cy="2011680"/>
+          </a:xfrm>
+          <a:prstGeom prst="roundRect">
+            <a:avLst/>
+          </a:prstGeom>
+          <a:solidFill>
+            <a:srgbClr val="141428"/>
+          </a:solidFill>
+          <a:ln w="19050">
+            <a:solidFill>
+              <a:srgbClr val="4ECCA3"/>
+            </a:solidFill>
+          </a:ln>
+        </p:spPr>
+        <p:style>
+          <a:lnRef idx="1">
+            <a:schemeClr val="accent1"/>
+          </a:lnRef>
+          <a:fillRef idx="3">
+            <a:schemeClr val="accent1"/>
+          </a:fillRef>
+          <a:effectRef idx="2">
+            <a:schemeClr val="accent1"/>
+          </a:effectRef>
+          <a:fontRef idx="minor">
+            <a:schemeClr val="lt1"/>
+          </a:fontRef>
+        </p:style>
+        <p:txBody>
+          <a:bodyPr rtlCol="0" anchor="ctr" wrap="square"/>
+          <a:lstStyle/>
+          <a:p>
+            <a:pPr algn="ctr">
+              <a:defRPr sz="1400" b="1">
+                <a:solidFill>
+                  <a:srgbClr val="4ECCA3"/>
+                </a:solidFill>
+              </a:defRPr>
+            </a:pPr>
+            <a:r>
+              <a:t>🚀 کاهش به خطی O(N + M)</a:t>
+            </a:r>
+          </a:p>
+          <a:p>
+            <a:pPr>
+              <a:defRPr sz="1100">
+                <a:solidFill>
+                  <a:srgbClr val="DDE1F5"/>
+                </a:solidFill>
+              </a:defRPr>
+            </a:pPr>
+            <a:r>
+              <a:t>کل هزینه به O(N + M) تبدیل شده و حتی برای ۱۰,۰۰۰ کارت در کسری از میلی‌ثانیه اجرا می‌شود.</a:t>
+            </a:r>
+          </a:p>
+        </p:txBody>
+      </p:sp>
+      <p:sp>
+        <p:nvSpPr>
+          <p:cNvPr id="6" name="Rounded Rectangle 5"/>
+          <p:cNvSpPr/>
+          <p:nvPr/>
+        </p:nvSpPr>
+        <p:spPr>
+          <a:xfrm>
+            <a:off x="731520" y="3703320"/>
+            <a:ext cx="10698480" cy="2633472"/>
+          </a:xfrm>
+          <a:prstGeom prst="roundRect">
+            <a:avLst/>
+          </a:prstGeom>
+          <a:solidFill>
+            <a:srgbClr val="08080F"/>
+          </a:solidFill>
+          <a:ln w="12700">
+            <a:solidFill>
+              <a:srgbClr val="7C8FF5"/>
+            </a:solidFill>
+          </a:ln>
+        </p:spPr>
+        <p:style>
+          <a:lnRef idx="1">
+            <a:schemeClr val="accent1"/>
+          </a:lnRef>
+          <a:fillRef idx="3">
+            <a:schemeClr val="accent1"/>
+          </a:fillRef>
+          <a:effectRef idx="2">
+            <a:schemeClr val="accent1"/>
+          </a:effectRef>
+          <a:fontRef idx="minor">
+            <a:schemeClr val="lt1"/>
+          </a:fontRef>
+        </p:style>
+        <p:txBody>
+          <a:bodyPr rtlCol="0" anchor="ctr" wrap="none"/>
+          <a:lstStyle/>
+          <a:p>
+            <a:pPr algn="l">
+              <a:defRPr sz="1100">
+                <a:solidFill>
+                  <a:srgbClr val="4ECCA3"/>
+                </a:solidFill>
+                <a:latin typeface="Consolas"/>
+              </a:defRPr>
+            </a:pPr>
+            <a:r>
+              <a:t>// ✅ رویکرد بهینه: تبدیل به Set و جستجوی آنی O(1)</a:t>
+            </a:r>
+          </a:p>
+          <a:p>
+            <a:pPr algn="l">
+              <a:defRPr sz="1100">
+                <a:solidFill>
+                  <a:srgbClr val="4ECCA3"/>
+                </a:solidFill>
+                <a:latin typeface="Consolas"/>
+              </a:defRPr>
+            </a:pPr>
+            <a:r>
+              <a:t>internal fun &lt;T&gt; syncCardStackState(</a:t>
+            </a:r>
+          </a:p>
+          <a:p>
+            <a:pPr algn="l">
+              <a:defRPr sz="1100">
+                <a:solidFill>
+                  <a:srgbClr val="4ECCA3"/>
+                </a:solidFill>
+                <a:latin typeface="Consolas"/>
+              </a:defRPr>
+            </a:pPr>
+            <a:r>
+              <a:t>    currentItems: List&lt;T&gt;,</a:t>
+            </a:r>
+          </a:p>
+          <a:p>
+            <a:pPr algn="l">
+              <a:defRPr sz="1100">
+                <a:solidFill>
+                  <a:srgbClr val="4ECCA3"/>
+                </a:solidFill>
+                <a:latin typeface="Consolas"/>
+              </a:defRPr>
+            </a:pPr>
+            <a:r>
+              <a:t>    newCardsList: List&lt;T&gt;,</a:t>
+            </a:r>
+          </a:p>
+          <a:p>
+            <a:pPr algn="l">
+              <a:defRPr sz="1100">
+                <a:solidFill>
+                  <a:srgbClr val="4ECCA3"/>
+                </a:solidFill>
+                <a:latin typeface="Consolas"/>
+              </a:defRPr>
+            </a:pPr>
+            <a:r>
+              <a:t>): List&lt;T&gt; {</a:t>
+            </a:r>
+          </a:p>
+          <a:p>
+            <a:pPr algn="l">
+              <a:defRPr sz="1100">
+                <a:solidFill>
+                  <a:srgbClr val="4ECCA3"/>
+                </a:solidFill>
+                <a:latin typeface="Consolas"/>
+              </a:defRPr>
+            </a:pPr>
+            <a:r>
+              <a:t>    val newCardsSet = newCardsList.toSet()</a:t>
+            </a:r>
+          </a:p>
+          <a:p>
+            <a:pPr algn="l">
+              <a:defRPr sz="1100">
+                <a:solidFill>
+                  <a:srgbClr val="4ECCA3"/>
+                </a:solidFill>
+                <a:latin typeface="Consolas"/>
+              </a:defRPr>
+            </a:pPr>
+            <a:r>
+              <a:t>    val currentItemsSet = currentItems.toSet()</a:t>
+            </a:r>
+          </a:p>
+          <a:p>
+            <a:pPr algn="l">
+              <a:defRPr sz="1100">
+                <a:solidFill>
+                  <a:srgbClr val="4ECCA3"/>
+                </a:solidFill>
+                <a:latin typeface="Consolas"/>
+              </a:defRPr>
+            </a:pPr>
+            <a:r>
+              <a:t>    val remainingOldItems = currentItems.filter { it in newCardsSet }</a:t>
+            </a:r>
+          </a:p>
+          <a:p>
+            <a:pPr algn="l">
+              <a:defRPr sz="1100">
+                <a:solidFill>
+                  <a:srgbClr val="4ECCA3"/>
+                </a:solidFill>
+                <a:latin typeface="Consolas"/>
+              </a:defRPr>
+            </a:pPr>
+            <a:r>
+              <a:t>    val newItems = newCardsList.filter { it !in currentItemsSet }</a:t>
+            </a:r>
+          </a:p>
+          <a:p>
+            <a:pPr algn="l">
+              <a:defRPr sz="1100">
+                <a:solidFill>
+                  <a:srgbClr val="4ECCA3"/>
+                </a:solidFill>
+                <a:latin typeface="Consolas"/>
+              </a:defRPr>
+            </a:pPr>
+            <a:r>
+              <a:t>    return remainingOldItems + newItems</a:t>
+            </a:r>
+          </a:p>
+          <a:p>
+            <a:pPr algn="l">
+              <a:defRPr sz="1100">
+                <a:solidFill>
+                  <a:srgbClr val="4ECCA3"/>
+                </a:solidFill>
+                <a:latin typeface="Consolas"/>
+              </a:defRPr>
+            </a:pPr>
+            <a:r>
+              <a:t>}</a:t>
+            </a:r>
+          </a:p>
+        </p:txBody>
+      </p:sp>
+      <p:sp>
+        <p:nvSpPr>
+          <p:cNvPr id="7" name="Rounded Rectangle 6"/>
+          <p:cNvSpPr/>
+          <p:nvPr/>
+        </p:nvSpPr>
+        <p:spPr>
+          <a:xfrm>
+            <a:off x="731520" y="5486400"/>
+            <a:ext cx="10698480" cy="822960"/>
+          </a:xfrm>
+          <a:prstGeom prst="roundRect">
+            <a:avLst/>
+          </a:prstGeom>
+          <a:solidFill>
+            <a:srgbClr val="1C1C38"/>
+          </a:solidFill>
+          <a:ln w="12700">
+            <a:solidFill>
+              <a:srgbClr val="7C8FF5"/>
+            </a:solidFill>
+          </a:ln>
+        </p:spPr>
+        <p:style>
+          <a:lnRef idx="1">
+            <a:schemeClr val="accent1"/>
+          </a:lnRef>
+          <a:fillRef idx="3">
+            <a:schemeClr val="accent1"/>
+          </a:fillRef>
+          <a:effectRef idx="2">
+            <a:schemeClr val="accent1"/>
+          </a:effectRef>
+          <a:fontRef idx="minor">
+            <a:schemeClr val="lt1"/>
+          </a:fontRef>
+        </p:style>
+        <p:txBody>
+          <a:bodyPr rtlCol="0" anchor="ctr" wrap="square"/>
+          <a:lstStyle/>
+          <a:p>
+            <a:pPr algn="ctr">
+              <a:defRPr sz="1200" i="1">
+                <a:solidFill>
+                  <a:srgbClr val="7C8FF5"/>
+                </a:solidFill>
+              </a:defRPr>
+            </a:pPr>
+            <a:r>
+              <a:t>«قاعده طلایی: همیشه پیش از فیلتر یا مقایسه اشتراک دو لیست در کاتلین، لیست مرجع را به Set تبدیل کنید.»</a:t>
+            </a:r>
+          </a:p>
+        </p:txBody>
+      </p:sp>
+    </p:spTree>
+  </p:cSld>
+  <p:clrMapOvr>
+    <a:masterClrMapping/>
+  </p:clrMapOvr>
+</p:sld>
+</file>
+
+<file path=ppt/slides/slide32.xml><?xml version="1.0" encoding="utf-8"?>
+<p:sld xmlns:a="http://schemas.openxmlformats.org/drawingml/2006/main" xmlns:p="http://schemas.openxmlformats.org/presentationml/2006/main" xmlns:r="http://schemas.openxmlformats.org/officeDocument/2006/relationships">
+  <p:cSld>
+    <p:spTree>
+      <p:nvGrpSpPr>
+        <p:cNvPr id="1" name=""/>
+        <p:cNvGrpSpPr/>
+        <p:nvPr/>
+      </p:nvGrpSpPr>
+      <p:grpSpPr/>
+      <p:sp>
+        <p:nvSpPr>
+          <p:cNvPr id="2" name="Rectangle 1"/>
+          <p:cNvSpPr/>
+          <p:nvPr/>
+        </p:nvSpPr>
+        <p:spPr>
+          <a:xfrm>
+            <a:off x="0" y="0"/>
+            <a:ext cx="12191695" cy="6858000"/>
+          </a:xfrm>
+          <a:prstGeom prst="rect">
+            <a:avLst/>
+          </a:prstGeom>
+          <a:solidFill>
+            <a:srgbClr val="0D0D1A"/>
+          </a:solidFill>
+          <a:ln>
+            <a:noFill/>
+          </a:ln>
+        </p:spPr>
+        <p:style>
+          <a:lnRef idx="1">
+            <a:schemeClr val="accent1"/>
+          </a:lnRef>
+          <a:fillRef idx="3">
+            <a:schemeClr val="accent1"/>
+          </a:fillRef>
+          <a:effectRef idx="2">
+            <a:schemeClr val="accent1"/>
+          </a:effectRef>
+          <a:fontRef idx="minor">
+            <a:schemeClr val="lt1"/>
+          </a:fontRef>
+        </p:style>
+        <p:txBody>
+          <a:bodyPr rtlCol="0" anchor="ctr"/>
+          <a:lstStyle/>
+          <a:p>
+            <a:pPr algn="ctr"/>
+          </a:p>
+        </p:txBody>
+      </p:sp>
+      <p:sp>
+        <p:nvSpPr>
+          <p:cNvPr id="3" name="TextBox 2"/>
+          <p:cNvSpPr txBox="1"/>
+          <p:nvPr/>
+        </p:nvSpPr>
+        <p:spPr>
+          <a:xfrm>
+            <a:off x="731520" y="365760"/>
+            <a:ext cx="10698480" cy="914400"/>
+          </a:xfrm>
+          <a:prstGeom prst="rect">
+            <a:avLst/>
+          </a:prstGeom>
+          <a:noFill/>
+        </p:spPr>
+        <p:txBody>
+          <a:bodyPr wrap="square">
+            <a:spAutoFit/>
+          </a:bodyPr>
+          <a:lstStyle/>
+          <a:p>
+            <a:pPr>
+              <a:defRPr sz="2400" b="1">
+                <a:solidFill>
+                  <a:srgbClr val="4ECCA3"/>
+                </a:solidFill>
+              </a:defRPr>
+            </a:pPr>
+            <a:r>
+              <a:t>برنامه اقدام · ACTION PLAN  |  جمع‌بندی و برنامه ۳۰ روزه آینده</a:t>
+            </a:r>
+          </a:p>
+          <a:p>
+            <a:pPr>
+              <a:defRPr sz="1400">
+                <a:solidFill>
+                  <a:srgbClr val="969EB4"/>
+                </a:solidFill>
+              </a:defRPr>
+            </a:pPr>
+            <a:r>
+              <a:t>نقشه راه ۴ هفته‌ای برای رسیدن به آمادگی در جلسات ارزیابی:</a:t>
+            </a:r>
+          </a:p>
+        </p:txBody>
+      </p:sp>
+      <p:sp>
+        <p:nvSpPr>
+          <p:cNvPr id="4" name="Rounded Rectangle 3"/>
+          <p:cNvSpPr/>
+          <p:nvPr/>
+        </p:nvSpPr>
+        <p:spPr>
+          <a:xfrm>
+            <a:off x="731520" y="1463040"/>
+            <a:ext cx="2503170" cy="2011680"/>
+          </a:xfrm>
+          <a:prstGeom prst="roundRect">
+            <a:avLst/>
+          </a:prstGeom>
+          <a:solidFill>
+            <a:srgbClr val="141428"/>
+          </a:solidFill>
+          <a:ln w="19050">
+            <a:solidFill>
+              <a:srgbClr val="4ECCA3"/>
+            </a:solidFill>
+          </a:ln>
+        </p:spPr>
+        <p:style>
+          <a:lnRef idx="1">
+            <a:schemeClr val="accent1"/>
+          </a:lnRef>
+          <a:fillRef idx="3">
+            <a:schemeClr val="accent1"/>
+          </a:fillRef>
+          <a:effectRef idx="2">
+            <a:schemeClr val="accent1"/>
+          </a:effectRef>
+          <a:fontRef idx="minor">
+            <a:schemeClr val="lt1"/>
+          </a:fontRef>
+        </p:style>
+        <p:txBody>
+          <a:bodyPr rtlCol="0" anchor="ctr" wrap="square"/>
+          <a:lstStyle/>
+          <a:p>
+            <a:pPr algn="ctr">
+              <a:defRPr sz="1400" b="1">
+                <a:solidFill>
+                  <a:srgbClr val="4ECCA3"/>
+                </a:solidFill>
+              </a:defRPr>
+            </a:pPr>
+            <a:r>
+              <a:t>هفته اول: مبانی آرایه و هش</a:t>
+            </a:r>
+          </a:p>
+          <a:p>
+            <a:pPr>
+              <a:defRPr sz="1100">
+                <a:solidFill>
+                  <a:srgbClr val="DDE1F5"/>
+                </a:solidFill>
+              </a:defRPr>
+            </a:pPr>
+            <a:r>
+              <a:t>حل ۵ مسئله Easy اول Blind 75 مانند Two Sum و Contains Duplicate.</a:t>
+            </a:r>
+          </a:p>
+        </p:txBody>
+      </p:sp>
+      <p:sp>
+        <p:nvSpPr>
+          <p:cNvPr id="5" name="Rounded Rectangle 4"/>
+          <p:cNvSpPr/>
+          <p:nvPr/>
+        </p:nvSpPr>
+        <p:spPr>
+          <a:xfrm>
+            <a:off x="3463289" y="1463040"/>
+            <a:ext cx="2503170" cy="2011680"/>
+          </a:xfrm>
+          <a:prstGeom prst="roundRect">
+            <a:avLst/>
+          </a:prstGeom>
+          <a:solidFill>
+            <a:srgbClr val="141428"/>
+          </a:solidFill>
+          <a:ln w="19050">
+            <a:solidFill>
+              <a:srgbClr val="7C8FF5"/>
+            </a:solidFill>
+          </a:ln>
+        </p:spPr>
+        <p:style>
+          <a:lnRef idx="1">
+            <a:schemeClr val="accent1"/>
+          </a:lnRef>
+          <a:fillRef idx="3">
+            <a:schemeClr val="accent1"/>
+          </a:fillRef>
+          <a:effectRef idx="2">
+            <a:schemeClr val="accent1"/>
+          </a:effectRef>
+          <a:fontRef idx="minor">
+            <a:schemeClr val="lt1"/>
+          </a:fontRef>
+        </p:style>
+        <p:txBody>
+          <a:bodyPr rtlCol="0" anchor="ctr" wrap="square"/>
+          <a:lstStyle/>
+          <a:p>
+            <a:pPr algn="ctr">
+              <a:defRPr sz="1400" b="1">
+                <a:solidFill>
+                  <a:srgbClr val="7C8FF5"/>
+                </a:solidFill>
+              </a:defRPr>
+            </a:pPr>
+            <a:r>
+              <a:t>هفته دوم: نشانگرها و پنجره</a:t>
+            </a:r>
+          </a:p>
+          <a:p>
+            <a:pPr>
+              <a:defRPr sz="1100">
+                <a:solidFill>
+                  <a:srgbClr val="DDE1F5"/>
+                </a:solidFill>
+              </a:defRPr>
+            </a:pPr>
+            <a:r>
+              <a:t>الگوهای Two Pointers و Sliding Window با مرور منظم مسائل هفته اول.</a:t>
+            </a:r>
+          </a:p>
+        </p:txBody>
+      </p:sp>
+      <p:sp>
+        <p:nvSpPr>
+          <p:cNvPr id="6" name="Rounded Rectangle 5"/>
+          <p:cNvSpPr/>
+          <p:nvPr/>
+        </p:nvSpPr>
+        <p:spPr>
+          <a:xfrm>
+            <a:off x="6195059" y="1463040"/>
+            <a:ext cx="2503170" cy="2011680"/>
+          </a:xfrm>
+          <a:prstGeom prst="roundRect">
+            <a:avLst/>
+          </a:prstGeom>
+          <a:solidFill>
+            <a:srgbClr val="141428"/>
+          </a:solidFill>
+          <a:ln w="19050">
+            <a:solidFill>
+              <a:srgbClr val="E9A84C"/>
+            </a:solidFill>
+          </a:ln>
+        </p:spPr>
+        <p:style>
+          <a:lnRef idx="1">
+            <a:schemeClr val="accent1"/>
+          </a:lnRef>
+          <a:fillRef idx="3">
+            <a:schemeClr val="accent1"/>
+          </a:fillRef>
+          <a:effectRef idx="2">
+            <a:schemeClr val="accent1"/>
+          </a:effectRef>
+          <a:fontRef idx="minor">
+            <a:schemeClr val="lt1"/>
+          </a:fontRef>
+        </p:style>
+        <p:txBody>
+          <a:bodyPr rtlCol="0" anchor="ctr" wrap="square"/>
+          <a:lstStyle/>
+          <a:p>
+            <a:pPr algn="ctr">
+              <a:defRPr sz="1400" b="1">
+                <a:solidFill>
+                  <a:srgbClr val="E9A84C"/>
+                </a:solidFill>
+              </a:defRPr>
+            </a:pPr>
+            <a:r>
+              <a:t>هفته سوم: ساختارها و پشته</a:t>
+            </a:r>
+          </a:p>
+          <a:p>
+            <a:pPr>
+              <a:defRPr sz="1100">
+                <a:solidFill>
+                  <a:srgbClr val="DDE1F5"/>
+                </a:solidFill>
+              </a:defRPr>
+            </a:pPr>
+            <a:r>
+              <a:t>درخت‌ها، پشته (Stack) و پیمایش‌های DFS و BFS پایه با رسم روی کاغذ.</a:t>
+            </a:r>
+          </a:p>
+        </p:txBody>
+      </p:sp>
+      <p:sp>
+        <p:nvSpPr>
+          <p:cNvPr id="7" name="Rounded Rectangle 6"/>
+          <p:cNvSpPr/>
+          <p:nvPr/>
+        </p:nvSpPr>
+        <p:spPr>
+          <a:xfrm>
+            <a:off x="8926830" y="1463040"/>
+            <a:ext cx="2503170" cy="2011680"/>
+          </a:xfrm>
+          <a:prstGeom prst="roundRect">
+            <a:avLst/>
+          </a:prstGeom>
+          <a:solidFill>
+            <a:srgbClr val="141428"/>
+          </a:solidFill>
+          <a:ln w="19050">
+            <a:solidFill>
+              <a:srgbClr val="4ECCA3"/>
+            </a:solidFill>
+          </a:ln>
+        </p:spPr>
+        <p:style>
+          <a:lnRef idx="1">
+            <a:schemeClr val="accent1"/>
+          </a:lnRef>
+          <a:fillRef idx="3">
+            <a:schemeClr val="accent1"/>
+          </a:fillRef>
+          <a:effectRef idx="2">
+            <a:schemeClr val="accent1"/>
+          </a:effectRef>
+          <a:fontRef idx="minor">
+            <a:schemeClr val="lt1"/>
+          </a:fontRef>
+        </p:style>
+        <p:txBody>
+          <a:bodyPr rtlCol="0" anchor="ctr" wrap="square"/>
+          <a:lstStyle/>
+          <a:p>
+            <a:pPr algn="ctr">
+              <a:defRPr sz="1400" b="1">
+                <a:solidFill>
+                  <a:srgbClr val="4ECCA3"/>
+                </a:solidFill>
+              </a:defRPr>
+            </a:pPr>
+            <a:r>
+              <a:t>هفته چهارم: تست‌های Medium</a:t>
+            </a:r>
+          </a:p>
+          <a:p>
+            <a:pPr>
+              <a:defRPr sz="1100">
+                <a:solidFill>
+                  <a:srgbClr val="DDE1F5"/>
+                </a:solidFill>
+              </a:defRPr>
+            </a:pPr>
+            <a:r>
+              <a:t>ورود به مسائل سطح Medium و تمرین با تایمر ۳۰ دقیقه‌ای ارزیابی.</a:t>
+            </a:r>
+          </a:p>
+        </p:txBody>
+      </p:sp>
+      <p:sp>
+        <p:nvSpPr>
+          <p:cNvPr id="8" name="Rounded Rectangle 7"/>
+          <p:cNvSpPr/>
+          <p:nvPr/>
+        </p:nvSpPr>
+        <p:spPr>
+          <a:xfrm>
+            <a:off x="731520" y="5486400"/>
+            <a:ext cx="10698480" cy="822960"/>
+          </a:xfrm>
+          <a:prstGeom prst="roundRect">
+            <a:avLst/>
+          </a:prstGeom>
+          <a:solidFill>
+            <a:srgbClr val="1C1C38"/>
+          </a:solidFill>
+          <a:ln w="12700">
+            <a:solidFill>
+              <a:srgbClr val="7C8FF5"/>
+            </a:solidFill>
+          </a:ln>
+        </p:spPr>
+        <p:style>
+          <a:lnRef idx="1">
+            <a:schemeClr val="accent1"/>
+          </a:lnRef>
+          <a:fillRef idx="3">
+            <a:schemeClr val="accent1"/>
+          </a:fillRef>
+          <a:effectRef idx="2">
+            <a:schemeClr val="accent1"/>
+          </a:effectRef>
+          <a:fontRef idx="minor">
+            <a:schemeClr val="lt1"/>
+          </a:fontRef>
+        </p:style>
+        <p:txBody>
+          <a:bodyPr rtlCol="0" anchor="ctr" wrap="square"/>
+          <a:lstStyle/>
+          <a:p>
+            <a:pPr algn="ctr">
+              <a:defRPr sz="1200" i="1">
+                <a:solidFill>
+                  <a:srgbClr val="7C8FF5"/>
+                </a:solidFill>
+              </a:defRPr>
+            </a:pPr>
+            <a:r>
+              <a:t>«پیوستگی روزانه ۴۵ دقیقه تمرین عمیق، معجزه‌ای خلق می‌کند که تمرین‌های ۱۰ ساعته‌ی بی‌هدف هرگز نخواهد کرد.»</a:t>
+            </a:r>
+          </a:p>
+        </p:txBody>
+      </p:sp>
+    </p:spTree>
+  </p:cSld>
+  <p:clrMapOvr>
+    <a:masterClrMapping/>
+  </p:clrMapOvr>
+</p:sld>
+</file>
+
+<file path=ppt/slides/slide33.xml><?xml version="1.0" encoding="utf-8"?>
+<p:sld xmlns:a="http://schemas.openxmlformats.org/drawingml/2006/main" xmlns:p="http://schemas.openxmlformats.org/presentationml/2006/main" xmlns:r="http://schemas.openxmlformats.org/officeDocument/2006/relationships">
+  <p:cSld>
+    <p:spTree>
+      <p:nvGrpSpPr>
+        <p:cNvPr id="1" name=""/>
+        <p:cNvGrpSpPr/>
+        <p:nvPr/>
+      </p:nvGrpSpPr>
+      <p:grpSpPr/>
+      <p:sp>
+        <p:nvSpPr>
+          <p:cNvPr id="2" name="Rectangle 1"/>
+          <p:cNvSpPr/>
+          <p:nvPr/>
+        </p:nvSpPr>
+        <p:spPr>
+          <a:xfrm>
+            <a:off x="0" y="0"/>
+            <a:ext cx="12191695" cy="6858000"/>
+          </a:xfrm>
+          <a:prstGeom prst="rect">
+            <a:avLst/>
+          </a:prstGeom>
+          <a:solidFill>
+            <a:srgbClr val="0D0D1A"/>
+          </a:solidFill>
+          <a:ln>
+            <a:noFill/>
+          </a:ln>
+        </p:spPr>
+        <p:style>
+          <a:lnRef idx="1">
+            <a:schemeClr val="accent1"/>
+          </a:lnRef>
+          <a:fillRef idx="3">
+            <a:schemeClr val="accent1"/>
+          </a:fillRef>
+          <a:effectRef idx="2">
+            <a:schemeClr val="accent1"/>
+          </a:effectRef>
+          <a:fontRef idx="minor">
+            <a:schemeClr val="lt1"/>
+          </a:fontRef>
+        </p:style>
+        <p:txBody>
+          <a:bodyPr rtlCol="0" anchor="ctr"/>
+          <a:lstStyle/>
+          <a:p>
+            <a:pPr algn="ctr"/>
+          </a:p>
+        </p:txBody>
+      </p:sp>
+      <p:sp>
+        <p:nvSpPr>
+          <p:cNvPr id="3" name="TextBox 2"/>
+          <p:cNvSpPr txBox="1"/>
+          <p:nvPr/>
+        </p:nvSpPr>
+        <p:spPr>
+          <a:xfrm>
+            <a:off x="1371600" y="1645920"/>
+            <a:ext cx="9418320" cy="3657600"/>
+          </a:xfrm>
+          <a:prstGeom prst="rect">
+            <a:avLst/>
+          </a:prstGeom>
+          <a:noFill/>
+        </p:spPr>
+        <p:txBody>
+          <a:bodyPr wrap="square">
+            <a:spAutoFit/>
+          </a:bodyPr>
+          <a:lstStyle/>
+          <a:p>
+            <a:pPr algn="ctr">
+              <a:defRPr sz="4600" b="1">
+                <a:solidFill>
+                  <a:srgbClr val="4ECCA3"/>
+                </a:solidFill>
+              </a:defRPr>
+            </a:pPr>
+            <a:r>
+              <a:t>متشکرم از همراهی شما</a:t>
+            </a:r>
+          </a:p>
+          <a:p>
+            <a:pPr algn="ctr">
+              <a:defRPr sz="2800">
+                <a:solidFill>
+                  <a:srgbClr val="7C8FF5"/>
+                </a:solidFill>
+              </a:defRPr>
+            </a:pPr>
+            <a:r>
+              <a:t>پرسش و پاسخ (Q&amp;A)</a:t>
+            </a:r>
+          </a:p>
+          <a:p>
+            <a:br/>
+            <a:pPr algn="ctr">
+              <a:defRPr sz="2000">
+                <a:solidFill>
+                  <a:srgbClr val="DDE1F5"/>
+                </a:solidFill>
+              </a:defRPr>
+            </a:pPr>
+            <a:r>
+              <a:t>Milad Faridnia</a:t>
+            </a:r>
+          </a:p>
+          <a:p>
+            <a:pPr algn="ctr">
+              <a:defRPr sz="1400">
+                <a:solidFill>
+                  <a:srgbClr val="E9A84C"/>
+                </a:solidFill>
+              </a:defRPr>
+            </a:pPr>
+            <a:r>
+              <a:t>LeetCode.com · NeetCode.io · Blind 75</a:t>
             </a:r>
           </a:p>
         </p:txBody>

</xml_diff>